<commit_message>
fix(presentacion): usa nombres completos de los clasificadores
</commit_message>
<xml_diff>
--- a/documentacion/contexto/presentaciones_anteriores/defensa_fraude.pptx
+++ b/documentacion/contexto/presentaciones_anteriores/defensa_fraude.pptx
@@ -3616,7 +3616,7 @@
                 </a:solidFill>
                 <a:latin typeface="Arial"/>
               </a:rPr>
-              <a:t>k-NN · árbol · SVM · Random Forest propio</a:t>
+              <a:t>k-NN · árbol de decisión · SVM · Random Forest propio</a:t>
             </a:r>
           </a:p>
         </p:txBody>
@@ -4964,7 +4964,7 @@
                 </a:solidFill>
                 <a:latin typeface="Arial"/>
               </a:rPr>
-              <a:t>sensibilidad del bosque</a:t>
+              <a:t>sensibilidad de Random Forest</a:t>
             </a:r>
           </a:p>
         </p:txBody>
@@ -5124,7 +5124,7 @@
                 </a:solidFill>
                 <a:latin typeface="Arial"/>
               </a:rPr>
-              <a:t>precisión del bosque compensado</a:t>
+              <a:t>precisión de Random Forest compensado</a:t>
             </a:r>
           </a:p>
         </p:txBody>
@@ -5409,7 +5409,7 @@
                 </a:solidFill>
                 <a:latin typeface="Arial"/>
               </a:rPr>
-              <a:t>El bosque con submuestreo detecta 2,7 puntos porcentuales menos que el árbol compensado, pero eleva la precisión de 0,336 a 0,675.</a:t>
+              <a:t>Random Forest con submuestreo detecta 2,7 puntos porcentuales menos que el árbol de decisión compensado, pero eleva la precisión de 0,336 a 0,675.</a:t>
             </a:r>
           </a:p>
         </p:txBody>
@@ -7698,7 +7698,7 @@
                 </a:solidFill>
                 <a:latin typeface="Arial"/>
               </a:rPr>
-              <a:t>Rangos evaluados: k-NN n_neighbors=3, 5, 7; Árbol de decisión max_depth=5, 10, libre; min_samples_leaf=1, 5; SVM lineal C=0,1, 1, 10; Random Forest propio n_estimators=11, 21; max_depth=6, 12. El bosque usa max_features=√p.</a:t>
+              <a:t>Rangos evaluados: k-NN n_neighbors=3, 5, 7; Árbol de decisión max_depth=5, 10, libre; min_samples_leaf=1, 5; SVM lineal C=0,1, 1, 10; Random Forest propio n_estimators=11, 21; max_depth=6, 12. Random Forest usa max_features=√p.</a:t>
             </a:r>
           </a:p>
         </p:txBody>
@@ -13089,7 +13089,7 @@
                 </a:solidFill>
                 <a:latin typeface="Arial"/>
               </a:rPr>
-              <a:t>Árbol independiente</a:t>
+              <a:t>Árbol de decisión independiente</a:t>
             </a:r>
           </a:p>
         </p:txBody>

</xml_diff>